<commit_message>
Agrandit le logo client et corrige les mentions « trimestriel » figées dans le PowerPoint
- Le logo client est maintenant mis à l'échelle sur la hauteur (au moins
  celle du logo LEVAD de la page 1), plutôt que contraint dans une petite
  case — il ne paraît plus plus petit que le logo LEVAD.
- Plusieurs libellés étaient toujours écrits « trimestriel » même en
  périodicité mensuelle : l'en-tête « Loyer trimestriel » du tableau page 24,
  les titres « ... / TRIMESTRE » et les en-têtes « Loyer/TOTAL Trimestriel »
  des tableaux SA/SP page 25 suivent maintenant la périodicité choisie dans
  le simulateur (comme c'était déjà le cas page 29).

Co-Authored-By: Claude Sonnet 5 <noreply@anthropic.com>
Claude-Session: https://claude.ai/code/session_016JD1D1gE4y4CwLWd3hVqJG
</commit_message>
<xml_diff>
--- a/assets/template.pptx
+++ b/assets/template.pptx
@@ -17284,7 +17284,7 @@
                             <a:schemeClr val="tx1"/>
                           </a:solidFill>
                         </a:rPr>
-                        <a:t>Loyer trimestriel</a:t>
+                        <a:t>Loyer {{PER_ADJ_MASC_LC}}</a:t>
                       </a:r>
                     </a:p>
                   </a:txBody>
@@ -17597,7 +17597,7 @@
                 </a:solidFill>
                 <a:latin typeface="Noto Sans Bold"/>
               </a:rPr>
-              <a:t>SITUATION ACTUELLE € HT / TRIMESTRE</a:t>
+              <a:t>SITUATION ACTUELLE € HT / {{PER_UNIT}}</a:t>
             </a:r>
           </a:p>
         </p:txBody>
@@ -17638,7 +17638,7 @@
                 </a:solidFill>
                 <a:latin typeface="Noto Sans Bold"/>
               </a:rPr>
-              <a:t>SOLUTION PROPOSEE € HT / TRIMESTRE</a:t>
+              <a:t>SOLUTION PROPOSEE € HT / {{PER_UNIT}}</a:t>
             </a:r>
           </a:p>
         </p:txBody>
@@ -18101,7 +18101,7 @@
                           <a:ea typeface="Noto Sans" panose="020B0502040504020204" pitchFamily="34" charset="0"/>
                           <a:cs typeface="Noto Sans" panose="020B0502040504020204" pitchFamily="34" charset="0"/>
                         </a:rPr>
-                        <a:t>Trimestriel</a:t>
+                        <a:t>{{PER_ADJ_MASC}}</a:t>
                       </a:r>
                     </a:p>
                   </a:txBody>
@@ -18333,7 +18333,7 @@
                           <a:ea typeface="Noto Sans" panose="020B0502040504020204" pitchFamily="34" charset="0"/>
                           <a:cs typeface="Noto Sans" panose="020B0502040504020204" pitchFamily="34" charset="0"/>
                         </a:rPr>
-                        <a:t>Trimestriel</a:t>
+                        <a:t>{{PER_ADJ_MASC}}</a:t>
                       </a:r>
                     </a:p>
                   </a:txBody>
@@ -18852,7 +18852,7 @@
                           <a:ea typeface="Noto Sans" panose="020B0502040504020204" pitchFamily="34" charset="0"/>
                           <a:cs typeface="Noto Sans" panose="020B0502040504020204" pitchFamily="34" charset="0"/>
                         </a:rPr>
-                        <a:t>Trimestriel</a:t>
+                        <a:t>{{PER_ADJ_MASC}}</a:t>
                       </a:r>
                     </a:p>
                   </a:txBody>
@@ -19084,7 +19084,7 @@
                           <a:ea typeface="Noto Sans" panose="020B0502040504020204" pitchFamily="34" charset="0"/>
                           <a:cs typeface="Noto Sans" panose="020B0502040504020204" pitchFamily="34" charset="0"/>
                         </a:rPr>
-                        <a:t>Trimestriel</a:t>
+                        <a:t>{{PER_ADJ_MASC}}</a:t>
                       </a:r>
                     </a:p>
                   </a:txBody>

</xml_diff>